<commit_message>
Add team details (TrafficSolvers, IIIT Delhi) to title + closing slides
Co-Authored-By: Claude Opus 4.8 <noreply@anthropic.com>
</commit_message>
<xml_diff>
--- a/Gridlock_Pitch_Deck.pptx
+++ b/Gridlock_Pitch_Deck.pptx
@@ -3367,7 +3367,7 @@
         </p:nvSpPr>
         <p:spPr>
           <a:xfrm>
-            <a:off x="868680" y="5029200"/>
+            <a:off x="868680" y="4754880"/>
             <a:ext cx="3840480" cy="25400"/>
           </a:xfrm>
           <a:prstGeom prst="rect">
@@ -3411,8 +3411,8 @@
         </p:nvSpPr>
         <p:spPr>
           <a:xfrm>
-            <a:off x="868680" y="5257800"/>
-            <a:ext cx="10515600" cy="822960"/>
+            <a:off x="868680" y="4937760"/>
+            <a:ext cx="10789920" cy="1554480"/>
           </a:xfrm>
           <a:prstGeom prst="rect">
             <a:avLst/>
@@ -3434,12 +3434,50 @@
               </a:spcAft>
             </a:pPr>
             <a:r>
-              <a:rPr sz="1500" b="1">
+              <a:rPr sz="1600" b="1">
+                <a:solidFill>
+                  <a:srgbClr val="FFE11B"/>
+                </a:solidFill>
+                <a:latin typeface="Calibri"/>
+              </a:rPr>
+              <a:t>Team TrafficSolvers — IIIT Delhi</a:t>
+            </a:r>
+          </a:p>
+          <a:p>
+            <a:pPr algn="l">
+              <a:spcBef>
+                <a:spcPts val="0"/>
+              </a:spcBef>
+              <a:spcAft>
+                <a:spcPts val="500"/>
+              </a:spcAft>
+            </a:pPr>
+            <a:r>
+              <a:rPr sz="1300" b="0">
                 <a:solidFill>
                   <a:srgbClr val="F2F5FA"/>
                 </a:solidFill>
                 <a:latin typeface="Calibri"/>
               </a:rPr>
+              <a:t>Ryan Bhan (Lead) · Kanan Mittal · Aditya Rawat · Hrithik Raj</a:t>
+            </a:r>
+          </a:p>
+          <a:p>
+            <a:pPr algn="l">
+              <a:spcBef>
+                <a:spcPts val="0"/>
+              </a:spcBef>
+              <a:spcAft>
+                <a:spcPts val="500"/>
+              </a:spcAft>
+            </a:pPr>
+            <a:r>
+              <a:rPr sz="1250" b="0">
+                <a:solidFill>
+                  <a:srgbClr val="9AA7B8"/>
+                </a:solidFill>
+                <a:latin typeface="Calibri"/>
+              </a:rPr>
               <a:t>Flipkart Gridlock Hackathon 2.0 · Round 2</a:t>
             </a:r>
           </a:p>
@@ -3453,7 +3491,7 @@
               </a:spcAft>
             </a:pPr>
             <a:r>
-              <a:rPr sz="1250" b="0">
+              <a:rPr sz="1150" b="0">
                 <a:solidFill>
                   <a:srgbClr val="9AA7B8"/>
                 </a:solidFill>
@@ -7667,7 +7705,7 @@
         </p:nvSpPr>
         <p:spPr>
           <a:xfrm>
-            <a:off x="868680" y="5029200"/>
+            <a:off x="868680" y="4937760"/>
             <a:ext cx="3840480" cy="25400"/>
           </a:xfrm>
           <a:prstGeom prst="rect">
@@ -7711,8 +7749,8 @@
         </p:nvSpPr>
         <p:spPr>
           <a:xfrm>
-            <a:off x="868680" y="5257800"/>
-            <a:ext cx="10515600" cy="822960"/>
+            <a:off x="868680" y="5120640"/>
+            <a:ext cx="10607040" cy="1371600"/>
           </a:xfrm>
           <a:prstGeom prst="rect">
             <a:avLst/>
@@ -7734,32 +7772,51 @@
               </a:spcAft>
             </a:pPr>
             <a:r>
-              <a:rPr sz="1600" b="1">
+              <a:rPr sz="1700" b="1">
                 <a:solidFill>
                   <a:srgbClr val="F2F5FA"/>
                 </a:solidFill>
                 <a:latin typeface="Calibri"/>
               </a:rPr>
-              <a:t>GRIDLOCK — Event-Driven Congestion Intelligence</a:t>
-            </a:r>
-          </a:p>
-          <a:p>
-            <a:pPr algn="l">
-              <a:spcBef>
-                <a:spcPts val="0"/>
-              </a:spcBef>
-              <a:spcAft>
-                <a:spcPts val="500"/>
-              </a:spcAft>
-            </a:pPr>
-            <a:r>
-              <a:rPr sz="1300" b="0">
+              <a:t>Team TrafficSolvers — IIIT Delhi</a:t>
+            </a:r>
+          </a:p>
+          <a:p>
+            <a:pPr algn="l">
+              <a:spcBef>
+                <a:spcPts val="0"/>
+              </a:spcBef>
+              <a:spcAft>
+                <a:spcPts val="500"/>
+              </a:spcAft>
+            </a:pPr>
+            <a:r>
+              <a:rPr sz="1350" b="0">
+                <a:solidFill>
+                  <a:srgbClr val="FFE11B"/>
+                </a:solidFill>
+                <a:latin typeface="Calibri"/>
+              </a:rPr>
+              <a:t>Ryan Bhan (Lead) · Kanan Mittal · Aditya Rawat · Hrithik Raj</a:t>
+            </a:r>
+          </a:p>
+          <a:p>
+            <a:pPr algn="l">
+              <a:spcBef>
+                <a:spcPts val="0"/>
+              </a:spcBef>
+              <a:spcAft>
+                <a:spcPts val="500"/>
+              </a:spcAft>
+            </a:pPr>
+            <a:r>
+              <a:rPr sz="1250" b="0">
                 <a:solidFill>
                   <a:srgbClr val="9AA7B8"/>
                 </a:solidFill>
                 <a:latin typeface="Calibri"/>
               </a:rPr>
-              <a:t>Flipkart Gridlock Hackathon 2.0 · Round 2</a:t>
+              <a:t>GRIDLOCK — Event-Driven Congestion Intelligence  ·  Flipkart Gridlock Hackathon 2.0 · Round 2</a:t>
             </a:r>
           </a:p>
         </p:txBody>

</xml_diff>

<commit_message>
Add narrated guided-tour demo video + correct team affiliations
- Gridlock_Demo.mp4: ~71s narrated, captioned walkthrough of the live dashboard
  with smooth fade transitions (replaces the earlier raw/jumpy capture).
- src/demo_shots.py: Playwright captures high-res per-tab screenshots.
- src/make_demo.py: composes branded 1080p scene frames (titles + captions),
  narrates via macOS `say`, assembles per-scene clips + concat (ffmpeg/videotoolbox).
- Removed src/record_demo.py (superseded). .gitignore: Office ~$ temp files.
- Deck: team affiliations — Kanan Mittal (IGDTUW), others (IIIT-D).

Co-Authored-By: Claude Opus 4.8 <noreply@anthropic.com>
</commit_message>
<xml_diff>
--- a/Gridlock_Pitch_Deck.pptx
+++ b/Gridlock_Pitch_Deck.pptx
@@ -3440,7 +3440,7 @@
                 </a:solidFill>
                 <a:latin typeface="Calibri"/>
               </a:rPr>
-              <a:t>Team TrafficSolvers — IIIT Delhi</a:t>
+              <a:t>Team TrafficSolvers</a:t>
             </a:r>
           </a:p>
           <a:p>
@@ -3459,7 +3459,7 @@
                 </a:solidFill>
                 <a:latin typeface="Calibri"/>
               </a:rPr>
-              <a:t>Ryan Bhan (Lead) · Kanan Mittal · Aditya Rawat · Hrithik Raj</a:t>
+              <a:t>Ryan Bhan (Lead, IIIT-D) · Kanan Mittal (IGDTUW) · Aditya Rawat (IIIT-D) · Hrithik Raj (IIIT-D)</a:t>
             </a:r>
           </a:p>
           <a:p>
@@ -7778,7 +7778,7 @@
                 </a:solidFill>
                 <a:latin typeface="Calibri"/>
               </a:rPr>
-              <a:t>Team TrafficSolvers — IIIT Delhi</a:t>
+              <a:t>Team TrafficSolvers</a:t>
             </a:r>
           </a:p>
           <a:p>
@@ -7797,7 +7797,7 @@
                 </a:solidFill>
                 <a:latin typeface="Calibri"/>
               </a:rPr>
-              <a:t>Ryan Bhan (Lead) · Kanan Mittal · Aditya Rawat · Hrithik Raj</a:t>
+              <a:t>Ryan Bhan (Lead, IIIT-D) · Kanan Mittal (IGDTUW) · Aditya Rawat (IIIT-D) · Hrithik Raj (IIIT-D)</a:t>
             </a:r>
           </a:p>
           <a:p>

</xml_diff>